<commit_message>
docs: portada institucional, Times New Roman y evidencias RSU reales
- Portada según el modelo del grupo (escudo de la UNAJMA) en todos los documentos
- Fuente Times New Roman en documentos y presentación
- Parte 8 del informe, diapositiva 9 y 7_Evidencias_RSU con la demostración
  por Google Meet del 20/10/2026 y sus capturas

Co-Authored-By: Claude Opus 5.5 <noreply@anthropic.com>
</commit_message>
<xml_diff>
--- a/docs/entrega/6_Presentacion.pptx
+++ b/docs/entrega/6_Presentacion.pptx
@@ -1141,7 +1141,7 @@
           <a:lstStyle/>
           <a:p>
             <a:r>
-              <a:t>Presenta: Oscco Zarabia Rider Gilmar. Actividad RSU prevista, evidencias e indicadores. Actualizar esta diapositiva con los datos reales si la actividad ya se realizó.</a:t>
+              <a:t>Presenta: Oscco Zarabia Rider Gilmar. Actividad RSU: demostración virtual al docente de Turpo, evidencias y siguiente etapa en la institución.</a:t>
             </a:r>
           </a:p>
         </p:txBody>
@@ -4183,7 +4183,7 @@
                 <a:solidFill>
                   <a:srgbClr val="DBEAFE"/>
                 </a:solidFill>
-                <a:latin typeface="Calibri"/>
+                <a:latin typeface="Times New Roman"/>
               </a:rPr>
               <a:t>UNIVERSIDAD NACIONAL JOSÉ MARÍA ARGUEDAS</a:t>
             </a:r>
@@ -4218,7 +4218,7 @@
                 <a:solidFill>
                   <a:srgbClr val="DBEAFE"/>
                 </a:solidFill>
-                <a:latin typeface="Calibri"/>
+                <a:latin typeface="Times New Roman"/>
               </a:rPr>
               <a:t>Computación Gráfica (IIAD65) · 2026-II · Grupo 3</a:t>
             </a:r>
@@ -4253,7 +4253,7 @@
                 <a:solidFill>
                   <a:srgbClr val="FFFFFF"/>
                 </a:solidFill>
-                <a:latin typeface="Calibri"/>
+                <a:latin typeface="Times New Roman"/>
               </a:rPr>
               <a:t>GeoMatriz </a:t>
             </a:r>
@@ -4262,7 +4262,7 @@
                 <a:solidFill>
                   <a:srgbClr val="FBBF24"/>
                 </a:solidFill>
-                <a:latin typeface="Calibri"/>
+                <a:latin typeface="Times New Roman"/>
               </a:rPr>
               <a:t>2D</a:t>
             </a:r>
@@ -4297,7 +4297,7 @@
                 <a:solidFill>
                   <a:srgbClr val="DBEAFE"/>
                 </a:solidFill>
-                <a:latin typeface="Calibri"/>
+                <a:latin typeface="Times New Roman"/>
               </a:rPr>
               <a:t>Laboratorio interactivo de geometría 2D con matrices visibles</a:t>
             </a:r>
@@ -4332,7 +4332,7 @@
                 <a:solidFill>
                   <a:srgbClr val="FFFFFF"/>
                 </a:solidFill>
-                <a:latin typeface="Calibri"/>
+                <a:latin typeface="Times New Roman"/>
               </a:rPr>
               <a:t>Oscco Zarabia Rider Gilmar</a:t>
             </a:r>
@@ -4344,7 +4344,7 @@
                 <a:solidFill>
                   <a:srgbClr val="FFFFFF"/>
                 </a:solidFill>
-                <a:latin typeface="Calibri"/>
+                <a:latin typeface="Times New Roman"/>
               </a:rPr>
               <a:t>Vargas Alhuay Hernan</a:t>
             </a:r>
@@ -4356,7 +4356,7 @@
                 <a:solidFill>
                   <a:srgbClr val="FFFFFF"/>
                 </a:solidFill>
-                <a:latin typeface="Calibri"/>
+                <a:latin typeface="Times New Roman"/>
               </a:rPr>
               <a:t>Chilingano Lazo Albert</a:t>
             </a:r>
@@ -4391,7 +4391,7 @@
                 <a:solidFill>
                   <a:srgbClr val="DBEAFE"/>
                 </a:solidFill>
-                <a:latin typeface="Calibri"/>
+                <a:latin typeface="Times New Roman"/>
               </a:rPr>
               <a:t>Docente: Mtro. Jhamer Anderson Rojas Silva</a:t>
             </a:r>
@@ -4426,7 +4426,7 @@
                 <a:solidFill>
                   <a:srgbClr val="DBEAFE"/>
                 </a:solidFill>
-                <a:latin typeface="Calibri"/>
+                <a:latin typeface="Times New Roman"/>
               </a:rPr>
               <a:t>Andahuaylas, Perú · octubre de 2026</a:t>
             </a:r>
@@ -4511,7 +4511,7 @@
                 <a:solidFill>
                   <a:srgbClr val="FFFFFF"/>
                 </a:solidFill>
-                <a:latin typeface="Calibri"/>
+                <a:latin typeface="Times New Roman"/>
               </a:rPr>
               <a:t>Conclusiones</a:t>
             </a:r>
@@ -4563,7 +4563,7 @@
                 <a:solidFill>
                   <a:srgbClr val="1E3A8A"/>
                 </a:solidFill>
-                <a:latin typeface="Calibri"/>
+                <a:latin typeface="Times New Roman"/>
               </a:rPr>
               <a:t>1</a:t>
             </a:r>
@@ -4598,7 +4598,7 @@
                 <a:solidFill>
                   <a:srgbClr val="FFFFFF"/>
                 </a:solidFill>
-                <a:latin typeface="Calibri"/>
+                <a:latin typeface="Times New Roman"/>
               </a:rPr>
               <a:t>Se cumplió el objetivo: figura, matrices y coordenadas a la vez, sin instalación</a:t>
             </a:r>
@@ -4650,7 +4650,7 @@
                 <a:solidFill>
                   <a:srgbClr val="1E3A8A"/>
                 </a:solidFill>
-                <a:latin typeface="Calibri"/>
+                <a:latin typeface="Times New Roman"/>
               </a:rPr>
               <a:t>2</a:t>
             </a:r>
@@ -4685,7 +4685,7 @@
                 <a:solidFill>
                   <a:srgbClr val="FFFFFF"/>
                 </a:solidFill>
-                <a:latin typeface="Calibri"/>
+                <a:latin typeface="Times New Roman"/>
               </a:rPr>
               <a:t>Un solo concepto, el producto de matrices 3×3, sostiene todo el pipeline, incluido el viewport</a:t>
             </a:r>
@@ -4737,7 +4737,7 @@
                 <a:solidFill>
                   <a:srgbClr val="1E3A8A"/>
                 </a:solidFill>
-                <a:latin typeface="Calibri"/>
+                <a:latin typeface="Times New Roman"/>
               </a:rPr>
               <a:t>3</a:t>
             </a:r>
@@ -4772,7 +4772,7 @@
                 <a:solidFill>
                   <a:srgbClr val="FFFFFF"/>
                 </a:solidFill>
-                <a:latin typeface="Calibri"/>
+                <a:latin typeface="Times New Roman"/>
               </a:rPr>
               <a:t>Las pruebas con resultados calculados a mano detectaron errores que no se veían a simple vista</a:t>
             </a:r>
@@ -4853,7 +4853,7 @@
                 <a:solidFill>
                   <a:srgbClr val="FBBF24"/>
                 </a:solidFill>
-                <a:latin typeface="Calibri"/>
+                <a:latin typeface="Times New Roman"/>
               </a:rPr>
               <a:t>Trabajo futuro: </a:t>
             </a:r>
@@ -4862,7 +4862,7 @@
                 <a:solidFill>
                   <a:srgbClr val="FFFFFF"/>
                 </a:solidFill>
-                <a:latin typeface="Calibri"/>
+                <a:latin typeface="Times New Roman"/>
               </a:rPr>
               <a:t>recorte de polígonos (Sutherland–Hodgman), varias figuras a la vez, guardar escenas y animar la transformación.</a:t>
             </a:r>
@@ -4897,7 +4897,7 @@
                 <a:solidFill>
                   <a:srgbClr val="DBEAFE"/>
                 </a:solidFill>
-                <a:latin typeface="Calibri"/>
+                <a:latin typeface="Times New Roman"/>
               </a:rPr>
               <a:t>GeoMatriz 2D · Grupo 3 · Computación Gráfica (IIAD65)</a:t>
             </a:r>
@@ -4932,7 +4932,7 @@
                 <a:solidFill>
                   <a:srgbClr val="DBEAFE"/>
                 </a:solidFill>
-                <a:latin typeface="Calibri"/>
+                <a:latin typeface="Times New Roman"/>
               </a:rPr>
               <a:t>10</a:t>
             </a:r>
@@ -4993,7 +4993,7 @@
                 <a:solidFill>
                   <a:srgbClr val="1E3A8A"/>
                 </a:solidFill>
-                <a:latin typeface="Calibri"/>
+                <a:latin typeface="Times New Roman"/>
               </a:rPr>
               <a:t>El problema</a:t>
             </a:r>
@@ -5028,7 +5028,7 @@
                 <a:solidFill>
                   <a:srgbClr val="4B5563"/>
                 </a:solidFill>
-                <a:latin typeface="Calibri"/>
+                <a:latin typeface="Times New Roman"/>
               </a:rPr>
               <a:t>Las transformaciones geométricas se enseñan en papel</a:t>
             </a:r>
@@ -5126,7 +5126,7 @@
                 <a:solidFill>
                   <a:srgbClr val="1E3A8A"/>
                 </a:solidFill>
-                <a:latin typeface="Calibri"/>
+                <a:latin typeface="Times New Roman"/>
               </a:rPr>
               <a:t>1</a:t>
             </a:r>
@@ -5161,7 +5161,7 @@
                 <a:solidFill>
                   <a:srgbClr val="1E3A8A"/>
                 </a:solidFill>
-                <a:latin typeface="Calibri"/>
+                <a:latin typeface="Times New Roman"/>
               </a:rPr>
               <a:t>Se ve la fórmula, no el movimiento</a:t>
             </a:r>
@@ -5196,7 +5196,7 @@
                 <a:solidFill>
                   <a:srgbClr val="111827"/>
                 </a:solidFill>
-                <a:latin typeface="Calibri"/>
+                <a:latin typeface="Times New Roman"/>
               </a:rPr>
               <a:t>El estudiante no relaciona los números de la matriz con lo que le pasa a la figura.</a:t>
             </a:r>
@@ -5294,7 +5294,7 @@
                 <a:solidFill>
                   <a:srgbClr val="1E3A8A"/>
                 </a:solidFill>
-                <a:latin typeface="Calibri"/>
+                <a:latin typeface="Times New Roman"/>
               </a:rPr>
               <a:t>2</a:t>
             </a:r>
@@ -5329,7 +5329,7 @@
                 <a:solidFill>
                   <a:srgbClr val="1E3A8A"/>
                 </a:solidFill>
-                <a:latin typeface="Calibri"/>
+                <a:latin typeface="Times New Roman"/>
               </a:rPr>
               <a:t>El orden es difícil de comprobar</a:t>
             </a:r>
@@ -5364,7 +5364,7 @@
                 <a:solidFill>
                   <a:srgbClr val="111827"/>
                 </a:solidFill>
-                <a:latin typeface="Calibri"/>
+                <a:latin typeface="Times New Roman"/>
               </a:rPr>
               <a:t>Verificar a mano que T·R ≠ R·T o cómo cambia el área toma mucho tiempo.</a:t>
             </a:r>
@@ -5462,7 +5462,7 @@
                 <a:solidFill>
                   <a:srgbClr val="1E3A8A"/>
                 </a:solidFill>
-                <a:latin typeface="Calibri"/>
+                <a:latin typeface="Times New Roman"/>
               </a:rPr>
               <a:t>3</a:t>
             </a:r>
@@ -5497,7 +5497,7 @@
                 <a:solidFill>
                   <a:srgbClr val="1E3A8A"/>
                 </a:solidFill>
-                <a:latin typeface="Calibri"/>
+                <a:latin typeface="Times New Roman"/>
               </a:rPr>
               <a:t>Faltan herramientas locales</a:t>
             </a:r>
@@ -5532,7 +5532,7 @@
                 <a:solidFill>
                   <a:srgbClr val="111827"/>
                 </a:solidFill>
-                <a:latin typeface="Calibri"/>
+                <a:latin typeface="Times New Roman"/>
               </a:rPr>
               <a:t>No hay una herramienta gratuita, en español y sin internet que muestre figura, matrices y coordenadas a la vez.</a:t>
             </a:r>
@@ -5567,7 +5567,7 @@
                 <a:solidFill>
                   <a:srgbClr val="111827"/>
                 </a:solidFill>
-                <a:latin typeface="Calibri"/>
+                <a:latin typeface="Times New Roman"/>
               </a:rPr>
               <a:t>Beneficiario: </a:t>
             </a:r>
@@ -5576,9 +5576,9 @@
                 <a:solidFill>
                   <a:srgbClr val="111827"/>
                 </a:solidFill>
-                <a:latin typeface="Calibri"/>
-              </a:rPr>
-              <a:t>docentes de matemática de Andahuaylas y sus estudiantes.</a:t>
+                <a:latin typeface="Times New Roman"/>
+              </a:rPr>
+              <a:t>docentes de una institución educativa de Turpo (Andahuaylas) y sus estudiantes.</a:t>
             </a:r>
           </a:p>
         </p:txBody>
@@ -5611,7 +5611,7 @@
                 <a:solidFill>
                   <a:srgbClr val="4B5563"/>
                 </a:solidFill>
-                <a:latin typeface="Calibri"/>
+                <a:latin typeface="Times New Roman"/>
               </a:rPr>
               <a:t>GeoMatriz 2D · Grupo 3 · Computación Gráfica (IIAD65)</a:t>
             </a:r>
@@ -5646,7 +5646,7 @@
                 <a:solidFill>
                   <a:srgbClr val="4B5563"/>
                 </a:solidFill>
-                <a:latin typeface="Calibri"/>
+                <a:latin typeface="Times New Roman"/>
               </a:rPr>
               <a:t>2</a:t>
             </a:r>
@@ -5707,7 +5707,7 @@
                 <a:solidFill>
                   <a:srgbClr val="1E3A8A"/>
                 </a:solidFill>
-                <a:latin typeface="Calibri"/>
+                <a:latin typeface="Times New Roman"/>
               </a:rPr>
               <a:t>Objetivo y solución</a:t>
             </a:r>
@@ -5788,7 +5788,7 @@
                 <a:solidFill>
                   <a:srgbClr val="FFFFFF"/>
                 </a:solidFill>
-                <a:latin typeface="Calibri"/>
+                <a:latin typeface="Times New Roman"/>
               </a:rPr>
               <a:t>Construir figuras 2D y aplicarles traslación, rotación y escalado con matrices homogéneas de 3×3, mostrando a la vez la figura, las matrices y las coordenadas.</a:t>
             </a:r>
@@ -5828,7 +5828,7 @@
                 <a:solidFill>
                   <a:srgbClr val="111827"/>
                 </a:solidFill>
-                <a:latin typeface="Calibri"/>
+                <a:latin typeface="Times New Roman"/>
               </a:rPr>
               <a:t>Dibujo al estilo GeoGebra: </a:t>
             </a:r>
@@ -5837,7 +5837,7 @@
                 <a:solidFill>
                   <a:srgbClr val="111827"/>
                 </a:solidFill>
-                <a:latin typeface="Calibri"/>
+                <a:latin typeface="Times New Roman"/>
               </a:rPr>
               <a:t>Punto, Segmento, Polígono, Mover</a:t>
             </a:r>
@@ -5854,7 +5854,7 @@
                 <a:solidFill>
                   <a:srgbClr val="111827"/>
                 </a:solidFill>
-                <a:latin typeface="Calibri"/>
+                <a:latin typeface="Times New Roman"/>
               </a:rPr>
               <a:t>Matrices visibles: </a:t>
             </a:r>
@@ -5863,7 +5863,7 @@
                 <a:solidFill>
                   <a:srgbClr val="111827"/>
                 </a:solidFill>
-                <a:latin typeface="Calibri"/>
+                <a:latin typeface="Times New Roman"/>
               </a:rPr>
               <a:t>cada Mᵢ, la compuesta M y det(M)</a:t>
             </a:r>
@@ -5880,7 +5880,7 @@
                 <a:solidFill>
                   <a:srgbClr val="111827"/>
                 </a:solidFill>
-                <a:latin typeface="Calibri"/>
+                <a:latin typeface="Times New Roman"/>
               </a:rPr>
               <a:t>Paso a paso: </a:t>
             </a:r>
@@ -5889,7 +5889,7 @@
                 <a:solidFill>
                   <a:srgbClr val="111827"/>
                 </a:solidFill>
-                <a:latin typeface="Calibri"/>
+                <a:latin typeface="Times New Roman"/>
               </a:rPr>
               <a:t>el cálculo de cada punto con números</a:t>
             </a:r>
@@ -5906,7 +5906,7 @@
                 <a:solidFill>
                   <a:srgbClr val="111827"/>
                 </a:solidFill>
-                <a:latin typeface="Calibri"/>
+                <a:latin typeface="Times New Roman"/>
               </a:rPr>
               <a:t>Sin instalación: </a:t>
             </a:r>
@@ -5915,7 +5915,7 @@
                 <a:solidFill>
                   <a:srgbClr val="111827"/>
                 </a:solidFill>
-                <a:latin typeface="Calibri"/>
+                <a:latin typeface="Times New Roman"/>
               </a:rPr>
               <a:t>doble clic en index.html, sin internet</a:t>
             </a:r>
@@ -5979,7 +5979,7 @@
                 <a:solidFill>
                   <a:srgbClr val="4B5563"/>
                 </a:solidFill>
-                <a:latin typeface="Calibri"/>
+                <a:latin typeface="Times New Roman"/>
               </a:rPr>
               <a:t>GeoMatriz 2D · Grupo 3 · Computación Gráfica (IIAD65)</a:t>
             </a:r>
@@ -6014,7 +6014,7 @@
                 <a:solidFill>
                   <a:srgbClr val="4B5563"/>
                 </a:solidFill>
-                <a:latin typeface="Calibri"/>
+                <a:latin typeface="Times New Roman"/>
               </a:rPr>
               <a:t>3</a:t>
             </a:r>
@@ -6075,7 +6075,7 @@
                 <a:solidFill>
                   <a:srgbClr val="1E3A8A"/>
                 </a:solidFill>
-                <a:latin typeface="Calibri"/>
+                <a:latin typeface="Times New Roman"/>
               </a:rPr>
               <a:t>Diseño: arquitectura por capas</a:t>
             </a:r>
@@ -6139,7 +6139,7 @@
                 <a:solidFill>
                   <a:srgbClr val="111827"/>
                 </a:solidFill>
-                <a:latin typeface="Calibri"/>
+                <a:latin typeface="Times New Roman"/>
               </a:rPr>
               <a:t>Lógica sin DOM </a:t>
             </a:r>
@@ -6148,7 +6148,7 @@
                 <a:solidFill>
                   <a:srgbClr val="111827"/>
                 </a:solidFill>
-                <a:latin typeface="Calibri"/>
+                <a:latin typeface="Times New Roman"/>
               </a:rPr>
               <a:t>(math, scene): se prueba sola con 39 pruebas</a:t>
             </a:r>
@@ -6165,7 +6165,7 @@
                 <a:solidFill>
                   <a:srgbClr val="111827"/>
                 </a:solidFill>
-                <a:latin typeface="Calibri"/>
+                <a:latin typeface="Times New Roman"/>
               </a:rPr>
               <a:t>Renderizador </a:t>
             </a:r>
@@ -6174,7 +6174,7 @@
                 <a:solidFill>
                   <a:srgbClr val="111827"/>
                 </a:solidFill>
-                <a:latin typeface="Calibri"/>
+                <a:latin typeface="Times New Roman"/>
               </a:rPr>
               <a:t>solo dibuja en Canvas 2D</a:t>
             </a:r>
@@ -6191,7 +6191,7 @@
                 <a:solidFill>
                   <a:srgbClr val="111827"/>
                 </a:solidFill>
-                <a:latin typeface="Calibri"/>
+                <a:latin typeface="Times New Roman"/>
               </a:rPr>
               <a:t>Interfaz </a:t>
             </a:r>
@@ -6200,7 +6200,7 @@
                 <a:solidFill>
                   <a:srgbClr val="111827"/>
                 </a:solidFill>
-                <a:latin typeface="Calibri"/>
+                <a:latin typeface="Times New Roman"/>
               </a:rPr>
               <a:t>conecta controles y estado</a:t>
             </a:r>
@@ -6217,7 +6217,7 @@
                 <a:solidFill>
                   <a:srgbClr val="111827"/>
                 </a:solidFill>
-                <a:latin typeface="Calibri"/>
+                <a:latin typeface="Times New Roman"/>
               </a:rPr>
               <a:t>Scripts clásicos </a:t>
             </a:r>
@@ -6226,7 +6226,7 @@
                 <a:solidFill>
                   <a:srgbClr val="111827"/>
                 </a:solidFill>
-                <a:latin typeface="Calibri"/>
+                <a:latin typeface="Times New Roman"/>
               </a:rPr>
               <a:t>en el espacio de nombres Geo: abre con doble clic</a:t>
             </a:r>
@@ -6243,7 +6243,7 @@
                 <a:solidFill>
                   <a:srgbClr val="111827"/>
                 </a:solidFill>
-                <a:latin typeface="Calibri"/>
+                <a:latin typeface="Times New Roman"/>
               </a:rPr>
               <a:t>Sin bibliotecas: </a:t>
             </a:r>
@@ -6252,7 +6252,7 @@
                 <a:solidFill>
                   <a:srgbClr val="111827"/>
                 </a:solidFill>
-                <a:latin typeface="Calibri"/>
+                <a:latin typeface="Times New Roman"/>
               </a:rPr>
               <a:t>todas las matrices las programó el grupo</a:t>
             </a:r>
@@ -6287,7 +6287,7 @@
                 <a:solidFill>
                   <a:srgbClr val="4B5563"/>
                 </a:solidFill>
-                <a:latin typeface="Calibri"/>
+                <a:latin typeface="Times New Roman"/>
               </a:rPr>
               <a:t>GeoMatriz 2D · Grupo 3 · Computación Gráfica (IIAD65)</a:t>
             </a:r>
@@ -6322,7 +6322,7 @@
                 <a:solidFill>
                   <a:srgbClr val="4B5563"/>
                 </a:solidFill>
-                <a:latin typeface="Calibri"/>
+                <a:latin typeface="Times New Roman"/>
               </a:rPr>
               <a:t>4</a:t>
             </a:r>
@@ -6383,7 +6383,7 @@
                 <a:solidFill>
                   <a:srgbClr val="1E3A8A"/>
                 </a:solidFill>
-                <a:latin typeface="Calibri"/>
+                <a:latin typeface="Times New Roman"/>
               </a:rPr>
               <a:t>Algoritmos: matrices homogéneas</a:t>
             </a:r>
@@ -6418,7 +6418,7 @@
                 <a:solidFill>
                   <a:srgbClr val="4B5563"/>
                 </a:solidFill>
-                <a:latin typeface="Calibri"/>
+                <a:latin typeface="Times New Roman"/>
               </a:rPr>
               <a:t>Un punto (x, y) se escribe como P = [x, y, 1]ᵀ; así la traslación también es un producto de matrices</a:t>
             </a:r>
@@ -8179,7 +8179,7 @@
                 <a:solidFill>
                   <a:srgbClr val="1E3A8A"/>
                 </a:solidFill>
-                <a:latin typeface="Calibri"/>
+                <a:latin typeface="Times New Roman"/>
               </a:rPr>
               <a:t>Ejemplo: rotar A = (1, 1) 90° y luego trasladar (2, 1)</a:t>
             </a:r>
@@ -8214,7 +8214,7 @@
                 <a:solidFill>
                   <a:srgbClr val="111827"/>
                 </a:solidFill>
-                <a:latin typeface="Calibri"/>
+                <a:latin typeface="Times New Roman"/>
               </a:rPr>
               <a:t>R(90°)·A = </a:t>
             </a:r>
@@ -8235,7 +8235,7 @@
                 <a:solidFill>
                   <a:srgbClr val="111827"/>
                 </a:solidFill>
-                <a:latin typeface="Calibri"/>
+                <a:latin typeface="Times New Roman"/>
               </a:rPr>
               <a:t>T(2, 1)·(−1, 1) = </a:t>
             </a:r>
@@ -8253,7 +8253,7 @@
                 <a:solidFill>
                   <a:srgbClr val="059669"/>
                 </a:solidFill>
-                <a:latin typeface="Calibri"/>
+                <a:latin typeface="Times New Roman"/>
               </a:rPr>
               <a:t>   → A′ = (1, 2) ✓ coincide con el programa</a:t>
             </a:r>
@@ -8288,7 +8288,7 @@
                 <a:solidFill>
                   <a:srgbClr val="4B5563"/>
                 </a:solidFill>
-                <a:latin typeface="Calibri"/>
+                <a:latin typeface="Times New Roman"/>
               </a:rPr>
               <a:t>GeoMatriz 2D · Grupo 3 · Computación Gráfica (IIAD65)</a:t>
             </a:r>
@@ -8323,7 +8323,7 @@
                 <a:solidFill>
                   <a:srgbClr val="4B5563"/>
                 </a:solidFill>
-                <a:latin typeface="Calibri"/>
+                <a:latin typeface="Times New Roman"/>
               </a:rPr>
               <a:t>5</a:t>
             </a:r>
@@ -8384,7 +8384,7 @@
                 <a:solidFill>
                   <a:srgbClr val="1E3A8A"/>
                 </a:solidFill>
-                <a:latin typeface="Calibri"/>
+                <a:latin typeface="Times New Roman"/>
               </a:rPr>
               <a:t>Composición, pivote y viewport</a:t>
             </a:r>
@@ -8436,7 +8436,7 @@
                 <a:solidFill>
                   <a:srgbClr val="1E3A8A"/>
                 </a:solidFill>
-                <a:latin typeface="Calibri"/>
+                <a:latin typeface="Times New Roman"/>
               </a:rPr>
               <a:t>1</a:t>
             </a:r>
@@ -8471,7 +8471,7 @@
                 <a:solidFill>
                   <a:srgbClr val="1E3A8A"/>
                 </a:solidFill>
-                <a:latin typeface="Calibri"/>
+                <a:latin typeface="Times New Roman"/>
               </a:rPr>
               <a:t>Composición</a:t>
             </a:r>
@@ -8541,7 +8541,7 @@
                 <a:solidFill>
                   <a:srgbClr val="4B5563"/>
                 </a:solidFill>
-                <a:latin typeface="Calibri"/>
+                <a:latin typeface="Times New Roman"/>
               </a:rPr>
               <a:t>La primera transformación aplicada queda a la derecha. Como el producto no es conmutativo, el orden importa.</a:t>
             </a:r>
@@ -8593,7 +8593,7 @@
                 <a:solidFill>
                   <a:srgbClr val="1E3A8A"/>
                 </a:solidFill>
-                <a:latin typeface="Calibri"/>
+                <a:latin typeface="Times New Roman"/>
               </a:rPr>
               <a:t>2</a:t>
             </a:r>
@@ -8628,7 +8628,7 @@
                 <a:solidFill>
                   <a:srgbClr val="1E3A8A"/>
                 </a:solidFill>
-                <a:latin typeface="Calibri"/>
+                <a:latin typeface="Times New Roman"/>
               </a:rPr>
               <a:t>Pivote</a:t>
             </a:r>
@@ -8698,7 +8698,7 @@
                 <a:solidFill>
                   <a:srgbClr val="4B5563"/>
                 </a:solidFill>
-                <a:latin typeface="Calibri"/>
+                <a:latin typeface="Times New Roman"/>
               </a:rPr>
               <a:t>Llevar el pivote al origen, girar o escalar, y regresar. El pivote puede ser el origen, el centroide o un punto.</a:t>
             </a:r>
@@ -8750,7 +8750,7 @@
                 <a:solidFill>
                   <a:srgbClr val="1E3A8A"/>
                 </a:solidFill>
-                <a:latin typeface="Calibri"/>
+                <a:latin typeface="Times New Roman"/>
               </a:rPr>
               <a:t>3</a:t>
             </a:r>
@@ -8785,7 +8785,7 @@
                 <a:solidFill>
                   <a:srgbClr val="1E3A8A"/>
                 </a:solidFill>
-                <a:latin typeface="Calibri"/>
+                <a:latin typeface="Times New Roman"/>
               </a:rPr>
               <a:t>Viewport</a:t>
             </a:r>
@@ -8855,7 +8855,7 @@
                 <a:solidFill>
                   <a:srgbClr val="4B5563"/>
                 </a:solidFill>
-                <a:latin typeface="Calibri"/>
+                <a:latin typeface="Times New Roman"/>
               </a:rPr>
               <a:t>V = [[k, 0, cᵤ], [0, −k, cᵥ], [0, 0, 1]]: zoom k y −k para invertir el eje Y de la pantalla.</a:t>
             </a:r>
@@ -8919,7 +8919,7 @@
                 <a:solidFill>
                   <a:srgbClr val="111827"/>
                 </a:solidFill>
-                <a:latin typeface="Calibri"/>
+                <a:latin typeface="Times New Roman"/>
               </a:rPr>
               <a:t>T·R ≠ R·T: </a:t>
             </a:r>
@@ -8928,7 +8928,7 @@
                 <a:solidFill>
                   <a:srgbClr val="111827"/>
                 </a:solidFill>
-                <a:latin typeface="Calibri"/>
+                <a:latin typeface="Times New Roman"/>
               </a:rPr>
               <a:t>con P = (1, 0), rotar 90° y trasladar (2, 0) da (2, 1); en el orden inverso da (0, 3). En morado, el resultado con el orden inverso.</a:t>
             </a:r>
@@ -8963,7 +8963,7 @@
                 <a:solidFill>
                   <a:srgbClr val="4B5563"/>
                 </a:solidFill>
-                <a:latin typeface="Calibri"/>
+                <a:latin typeface="Times New Roman"/>
               </a:rPr>
               <a:t>GeoMatriz 2D · Grupo 3 · Computación Gráfica (IIAD65)</a:t>
             </a:r>
@@ -8998,7 +8998,7 @@
                 <a:solidFill>
                   <a:srgbClr val="4B5563"/>
                 </a:solidFill>
-                <a:latin typeface="Calibri"/>
+                <a:latin typeface="Times New Roman"/>
               </a:rPr>
               <a:t>6</a:t>
             </a:r>
@@ -9059,7 +9059,7 @@
                 <a:solidFill>
                   <a:srgbClr val="1E3A8A"/>
                 </a:solidFill>
-                <a:latin typeface="Calibri"/>
+                <a:latin typeface="Times New Roman"/>
               </a:rPr>
               <a:t>Demostración en vivo</a:t>
             </a:r>
@@ -9111,7 +9111,7 @@
                 <a:solidFill>
                   <a:srgbClr val="1E3A8A"/>
                 </a:solidFill>
-                <a:latin typeface="Calibri"/>
+                <a:latin typeface="Times New Roman"/>
               </a:rPr>
               <a:t>1</a:t>
             </a:r>
@@ -9146,7 +9146,7 @@
                 <a:solidFill>
                   <a:srgbClr val="111827"/>
                 </a:solidFill>
-                <a:latin typeface="Calibri"/>
+                <a:latin typeface="Times New Roman"/>
               </a:rPr>
               <a:t>Dibujar un triángulo con la herramienta Polígono</a:t>
             </a:r>
@@ -9198,7 +9198,7 @@
                 <a:solidFill>
                   <a:srgbClr val="1E3A8A"/>
                 </a:solidFill>
-                <a:latin typeface="Calibri"/>
+                <a:latin typeface="Times New Roman"/>
               </a:rPr>
               <a:t>2</a:t>
             </a:r>
@@ -9233,7 +9233,7 @@
                 <a:solidFill>
                   <a:srgbClr val="111827"/>
                 </a:solidFill>
-                <a:latin typeface="Calibri"/>
+                <a:latin typeface="Times New Roman"/>
               </a:rPr>
               <a:t>Agregar Rotación 90° y Traslación (2, 1)</a:t>
             </a:r>
@@ -9285,7 +9285,7 @@
                 <a:solidFill>
                   <a:srgbClr val="1E3A8A"/>
                 </a:solidFill>
-                <a:latin typeface="Calibri"/>
+                <a:latin typeface="Times New Roman"/>
               </a:rPr>
               <a:t>3</a:t>
             </a:r>
@@ -9320,7 +9320,7 @@
                 <a:solidFill>
                   <a:srgbClr val="111827"/>
                 </a:solidFill>
-                <a:latin typeface="Calibri"/>
+                <a:latin typeface="Times New Roman"/>
               </a:rPr>
               <a:t>Leer M = M₂·M₁, det(M) y el paso a paso de A</a:t>
             </a:r>
@@ -9372,7 +9372,7 @@
                 <a:solidFill>
                   <a:srgbClr val="1E3A8A"/>
                 </a:solidFill>
-                <a:latin typeface="Calibri"/>
+                <a:latin typeface="Times New Roman"/>
               </a:rPr>
               <a:t>4</a:t>
             </a:r>
@@ -9407,7 +9407,7 @@
                 <a:solidFill>
                   <a:srgbClr val="111827"/>
                 </a:solidFill>
-                <a:latin typeface="Calibri"/>
+                <a:latin typeface="Times New Roman"/>
               </a:rPr>
               <a:t>Cambiar el orden con ↑ y comparar</a:t>
             </a:r>
@@ -9459,7 +9459,7 @@
                 <a:solidFill>
                   <a:srgbClr val="1E3A8A"/>
                 </a:solidFill>
-                <a:latin typeface="Calibri"/>
+                <a:latin typeface="Times New Roman"/>
               </a:rPr>
               <a:t>5</a:t>
             </a:r>
@@ -9494,7 +9494,7 @@
                 <a:solidFill>
                   <a:srgbClr val="111827"/>
                 </a:solidFill>
-                <a:latin typeface="Calibri"/>
+                <a:latin typeface="Times New Roman"/>
               </a:rPr>
               <a:t>Exportar el informe en PDF</a:t>
             </a:r>
@@ -9558,7 +9558,7 @@
                 <a:solidFill>
                   <a:srgbClr val="4B5563"/>
                 </a:solidFill>
-                <a:latin typeface="Calibri"/>
+                <a:latin typeface="Times New Roman"/>
               </a:rPr>
               <a:t>GeoMatriz 2D · Grupo 3 · Computación Gráfica (IIAD65)</a:t>
             </a:r>
@@ -9593,7 +9593,7 @@
                 <a:solidFill>
                   <a:srgbClr val="4B5563"/>
                 </a:solidFill>
-                <a:latin typeface="Calibri"/>
+                <a:latin typeface="Times New Roman"/>
               </a:rPr>
               <a:t>7</a:t>
             </a:r>
@@ -9654,7 +9654,7 @@
                 <a:solidFill>
                   <a:srgbClr val="1E3A8A"/>
                 </a:solidFill>
-                <a:latin typeface="Calibri"/>
+                <a:latin typeface="Times New Roman"/>
               </a:rPr>
               <a:t>Resultados</a:t>
             </a:r>
@@ -9735,7 +9735,7 @@
                 <a:solidFill>
                   <a:srgbClr val="059669"/>
                 </a:solidFill>
-                <a:latin typeface="Calibri"/>
+                <a:latin typeface="Times New Roman"/>
               </a:rPr>
               <a:t>39 / 39</a:t>
             </a:r>
@@ -9770,7 +9770,7 @@
                 <a:solidFill>
                   <a:srgbClr val="111827"/>
                 </a:solidFill>
-                <a:latin typeface="Calibri"/>
+                <a:latin typeface="Times New Roman"/>
               </a:rPr>
               <a:t>pruebas automáticas aprobadas</a:t>
             </a:r>
@@ -9851,7 +9851,7 @@
                 <a:solidFill>
                   <a:srgbClr val="2563EB"/>
                 </a:solidFill>
-                <a:latin typeface="Calibri"/>
+                <a:latin typeface="Times New Roman"/>
               </a:rPr>
               <a:t>2,4 ms</a:t>
             </a:r>
@@ -9886,7 +9886,7 @@
                 <a:solidFill>
                   <a:srgbClr val="111827"/>
                 </a:solidFill>
-                <a:latin typeface="Calibri"/>
+                <a:latin typeface="Times New Roman"/>
               </a:rPr>
               <a:t>por dibujo con 100 vértices (≥ 415 cuadros/s)</a:t>
             </a:r>
@@ -9967,7 +9967,7 @@
                 <a:solidFill>
                   <a:srgbClr val="7C3AED"/>
                 </a:solidFill>
-                <a:latin typeface="Calibri"/>
+                <a:latin typeface="Times New Roman"/>
               </a:rPr>
               <a:t>79</a:t>
             </a:r>
@@ -10002,7 +10002,7 @@
                 <a:solidFill>
                   <a:srgbClr val="111827"/>
                 </a:solidFill>
-                <a:latin typeface="Calibri"/>
+                <a:latin typeface="Times New Roman"/>
               </a:rPr>
               <a:t>pruebas manuales de interfaz registradas</a:t>
             </a:r>
@@ -10042,7 +10042,7 @@
                 <a:solidFill>
                   <a:srgbClr val="111827"/>
                 </a:solidFill>
-                <a:latin typeface="Calibri"/>
+                <a:latin typeface="Times New Roman"/>
               </a:rPr>
               <a:t>Resultados esperados calculados a mano antes de programar</a:t>
             </a:r>
@@ -10059,7 +10059,7 @@
                 <a:solidFill>
                   <a:srgbClr val="111827"/>
                 </a:solidFill>
-                <a:latin typeface="Calibri"/>
+                <a:latin typeface="Times New Roman"/>
               </a:rPr>
               <a:t>Funciona en computadora, tableta y celular sin desplazamiento horizontal</a:t>
             </a:r>
@@ -10076,7 +10076,7 @@
                 <a:solidFill>
                   <a:srgbClr val="111827"/>
                 </a:solidFill>
-                <a:latin typeface="Calibri"/>
+                <a:latin typeface="Times New Roman"/>
               </a:rPr>
               <a:t>Errores encontrados y corregidos: desfase de 1 px, plano sobre los resultados, menú Exportar, etiqueta del pivote</a:t>
             </a:r>
@@ -10169,7 +10169,7 @@
                 <a:solidFill>
                   <a:srgbClr val="4B5563"/>
                 </a:solidFill>
-                <a:latin typeface="Calibri"/>
+                <a:latin typeface="Times New Roman"/>
               </a:rPr>
               <a:t>GeoMatriz 2D · Grupo 3 · Computación Gráfica (IIAD65)</a:t>
             </a:r>
@@ -10204,7 +10204,7 @@
                 <a:solidFill>
                   <a:srgbClr val="4B5563"/>
                 </a:solidFill>
-                <a:latin typeface="Calibri"/>
+                <a:latin typeface="Times New Roman"/>
               </a:rPr>
               <a:t>8</a:t>
             </a:r>
@@ -10265,7 +10265,7 @@
                 <a:solidFill>
                   <a:srgbClr val="1E3A8A"/>
                 </a:solidFill>
-                <a:latin typeface="Calibri"/>
+                <a:latin typeface="Times New Roman"/>
               </a:rPr>
               <a:t>Responsabilidad Social Universitaria</a:t>
             </a:r>
@@ -10274,14 +10274,107 @@
       </p:sp>
       <p:sp>
         <p:nvSpPr>
-          <p:cNvPr id="3" name="Rounded Rectangle 2"/>
+          <p:cNvPr id="3" name="TextBox 2"/>
+          <p:cNvSpPr txBox="1"/>
+          <p:nvPr/>
+        </p:nvSpPr>
+        <p:spPr>
+          <a:xfrm>
+            <a:off x="548640" y="1097280"/>
+            <a:ext cx="11064240" cy="457200"/>
+          </a:xfrm>
+          <a:prstGeom prst="rect">
+            <a:avLst/>
+          </a:prstGeom>
+          <a:noFill/>
+        </p:spPr>
+        <p:txBody>
+          <a:bodyPr wrap="square" lIns="0" rIns="0" tIns="0" bIns="0" anchor="t">
+            <a:spAutoFit/>
+          </a:bodyPr>
+          <a:lstStyle/>
+          <a:p>
+            <a:pPr algn="l"/>
+            <a:r>
+              <a:rPr sz="1600" b="0" i="0">
+                <a:solidFill>
+                  <a:srgbClr val="4B5563"/>
+                </a:solidFill>
+                <a:latin typeface="Times New Roman"/>
+              </a:rPr>
+              <a:t>Primera etapa: demostración por Google Meet · 20 de octubre de 2026, 8:20 a. m.</a:t>
+            </a:r>
+          </a:p>
+        </p:txBody>
+      </p:sp>
+      <p:pic>
+        <p:nvPicPr>
+          <p:cNvPr id="4" name="Picture 3" descr="rsu_01_0825_triangulo_traslacion.png"/>
+          <p:cNvPicPr>
+            <a:picLocks noChangeAspect="1"/>
+          </p:cNvPicPr>
+          <p:nvPr/>
+        </p:nvPicPr>
+        <p:blipFill>
+          <a:blip r:embed="rId2"/>
+          <a:stretch>
+            <a:fillRect/>
+          </a:stretch>
+        </p:blipFill>
+        <p:spPr>
+          <a:xfrm>
+            <a:off x="548640" y="1730160"/>
+            <a:ext cx="5486400" cy="2208960"/>
+          </a:xfrm>
+          <a:prstGeom prst="rect">
+            <a:avLst/>
+          </a:prstGeom>
+          <a:ln w="12700">
+            <a:solidFill>
+              <a:srgbClr val="D1D5DB"/>
+            </a:solidFill>
+          </a:ln>
+        </p:spPr>
+      </p:pic>
+      <p:pic>
+        <p:nvPicPr>
+          <p:cNvPr id="5" name="Picture 4" descr="rsu_02_0826_borrar_figura.png"/>
+          <p:cNvPicPr>
+            <a:picLocks noChangeAspect="1"/>
+          </p:cNvPicPr>
+          <p:nvPr/>
+        </p:nvPicPr>
+        <p:blipFill>
+          <a:blip r:embed="rId3"/>
+          <a:stretch>
+            <a:fillRect/>
+          </a:stretch>
+        </p:blipFill>
+        <p:spPr>
+          <a:xfrm>
+            <a:off x="6434791" y="1691640"/>
+            <a:ext cx="4961216" cy="2286000"/>
+          </a:xfrm>
+          <a:prstGeom prst="rect">
+            <a:avLst/>
+          </a:prstGeom>
+          <a:ln w="12700">
+            <a:solidFill>
+              <a:srgbClr val="D1D5DB"/>
+            </a:solidFill>
+          </a:ln>
+        </p:spPr>
+      </p:pic>
+      <p:sp>
+        <p:nvSpPr>
+          <p:cNvPr id="6" name="Rounded Rectangle 5"/>
           <p:cNvSpPr/>
           <p:nvPr/>
         </p:nvSpPr>
         <p:spPr>
           <a:xfrm>
-            <a:off x="548640" y="1417320"/>
-            <a:ext cx="5440680" cy="1874519"/>
+            <a:off x="548640" y="4206240"/>
+            <a:ext cx="3611880" cy="1600200"/>
           </a:xfrm>
           <a:prstGeom prst="roundRect">
             <a:avLst>
@@ -10320,13 +10413,13 @@
       </p:sp>
       <p:sp>
         <p:nvSpPr>
-          <p:cNvPr id="4" name="Oval 3"/>
+          <p:cNvPr id="7" name="Oval 6"/>
           <p:cNvSpPr/>
           <p:nvPr/>
         </p:nvSpPr>
         <p:spPr>
           <a:xfrm>
-            <a:off x="822959" y="1691640"/>
+            <a:off x="777240" y="4434840"/>
             <a:ext cx="502920" cy="502920"/>
           </a:xfrm>
           <a:prstGeom prst="ellipse">
@@ -10363,7 +10456,7 @@
                 <a:solidFill>
                   <a:srgbClr val="1E3A8A"/>
                 </a:solidFill>
-                <a:latin typeface="Calibri"/>
+                <a:latin typeface="Times New Roman"/>
               </a:rPr>
               <a:t>1</a:t>
             </a:r>
@@ -10372,14 +10465,14 @@
       </p:sp>
       <p:sp>
         <p:nvSpPr>
-          <p:cNvPr id="5" name="TextBox 4"/>
+          <p:cNvPr id="8" name="TextBox 7"/>
           <p:cNvSpPr txBox="1"/>
           <p:nvPr/>
         </p:nvSpPr>
         <p:spPr>
           <a:xfrm>
-            <a:off x="1508760" y="1691640"/>
-            <a:ext cx="4206240" cy="457200"/>
+            <a:off x="1417319" y="4434840"/>
+            <a:ext cx="2651760" cy="457200"/>
           </a:xfrm>
           <a:prstGeom prst="rect">
             <a:avLst/>
@@ -10394,11 +10487,11 @@
           <a:p>
             <a:pPr algn="l"/>
             <a:r>
-              <a:rPr sz="2000" b="1" i="0">
+              <a:rPr sz="1800" b="1" i="0">
                 <a:solidFill>
                   <a:srgbClr val="1E3A8A"/>
                 </a:solidFill>
-                <a:latin typeface="Calibri"/>
+                <a:latin typeface="Times New Roman"/>
               </a:rPr>
               <a:t>Beneficiario</a:t>
             </a:r>
@@ -10407,14 +10500,14 @@
       </p:sp>
       <p:sp>
         <p:nvSpPr>
-          <p:cNvPr id="6" name="TextBox 5"/>
+          <p:cNvPr id="9" name="TextBox 8"/>
           <p:cNvSpPr txBox="1"/>
           <p:nvPr/>
         </p:nvSpPr>
         <p:spPr>
           <a:xfrm>
-            <a:off x="1508760" y="2194560"/>
-            <a:ext cx="4206240" cy="1005840"/>
+            <a:off x="777240" y="4937759"/>
+            <a:ext cx="3200400" cy="868680"/>
           </a:xfrm>
           <a:prstGeom prst="rect">
             <a:avLst/>
@@ -10429,27 +10522,27 @@
           <a:p>
             <a:pPr algn="l"/>
             <a:r>
-              <a:rPr sz="1500" b="0" i="0">
+              <a:rPr sz="1300" b="0" i="0">
                 <a:solidFill>
                   <a:srgbClr val="111827"/>
                 </a:solidFill>
-                <a:latin typeface="Calibri"/>
-              </a:rPr>
-              <a:t>Docentes de matemática de una institución educativa de Andahuaylas (por confirmar).</a:t>
-            </a:r>
-          </a:p>
-        </p:txBody>
-      </p:sp>
-      <p:sp>
-        <p:nvSpPr>
-          <p:cNvPr id="7" name="Rounded Rectangle 6"/>
+                <a:latin typeface="Times New Roman"/>
+              </a:rPr>
+              <a:t>Docente Valerio Palacios Chambi (estadístico e informático), de una institución educativa de Turpo.</a:t>
+            </a:r>
+          </a:p>
+        </p:txBody>
+      </p:sp>
+      <p:sp>
+        <p:nvSpPr>
+          <p:cNvPr id="10" name="Rounded Rectangle 9"/>
           <p:cNvSpPr/>
           <p:nvPr/>
         </p:nvSpPr>
         <p:spPr>
           <a:xfrm>
-            <a:off x="6172200" y="1417320"/>
-            <a:ext cx="5440680" cy="1874519"/>
+            <a:off x="4297679" y="4206240"/>
+            <a:ext cx="3611880" cy="1600200"/>
           </a:xfrm>
           <a:prstGeom prst="roundRect">
             <a:avLst>
@@ -10488,13 +10581,13 @@
       </p:sp>
       <p:sp>
         <p:nvSpPr>
-          <p:cNvPr id="8" name="Oval 7"/>
+          <p:cNvPr id="11" name="Oval 10"/>
           <p:cNvSpPr/>
           <p:nvPr/>
         </p:nvSpPr>
         <p:spPr>
           <a:xfrm>
-            <a:off x="6446520" y="1691640"/>
+            <a:off x="4526279" y="4434840"/>
             <a:ext cx="502920" cy="502920"/>
           </a:xfrm>
           <a:prstGeom prst="ellipse">
@@ -10531,7 +10624,7 @@
                 <a:solidFill>
                   <a:srgbClr val="1E3A8A"/>
                 </a:solidFill>
-                <a:latin typeface="Calibri"/>
+                <a:latin typeface="Times New Roman"/>
               </a:rPr>
               <a:t>2</a:t>
             </a:r>
@@ -10540,14 +10633,14 @@
       </p:sp>
       <p:sp>
         <p:nvSpPr>
-          <p:cNvPr id="9" name="TextBox 8"/>
+          <p:cNvPr id="12" name="TextBox 11"/>
           <p:cNvSpPr txBox="1"/>
           <p:nvPr/>
         </p:nvSpPr>
         <p:spPr>
           <a:xfrm>
-            <a:off x="7132320" y="1691640"/>
-            <a:ext cx="4206240" cy="457200"/>
+            <a:off x="5166359" y="4434840"/>
+            <a:ext cx="2651760" cy="457200"/>
           </a:xfrm>
           <a:prstGeom prst="rect">
             <a:avLst/>
@@ -10562,27 +10655,27 @@
           <a:p>
             <a:pPr algn="l"/>
             <a:r>
-              <a:rPr sz="2000" b="1" i="0">
+              <a:rPr sz="1800" b="1" i="0">
                 <a:solidFill>
                   <a:srgbClr val="1E3A8A"/>
                 </a:solidFill>
-                <a:latin typeface="Calibri"/>
-              </a:rPr>
-              <a:t>Actividad</a:t>
-            </a:r>
-          </a:p>
-        </p:txBody>
-      </p:sp>
-      <p:sp>
-        <p:nvSpPr>
-          <p:cNvPr id="10" name="TextBox 9"/>
+                <a:latin typeface="Times New Roman"/>
+              </a:rPr>
+              <a:t>Qué se mostró</a:t>
+            </a:r>
+          </a:p>
+        </p:txBody>
+      </p:sp>
+      <p:sp>
+        <p:nvSpPr>
+          <p:cNvPr id="13" name="TextBox 12"/>
           <p:cNvSpPr txBox="1"/>
           <p:nvPr/>
         </p:nvSpPr>
         <p:spPr>
           <a:xfrm>
-            <a:off x="7132320" y="2194560"/>
-            <a:ext cx="4206240" cy="1005840"/>
+            <a:off x="4526279" y="4937759"/>
+            <a:ext cx="3200400" cy="868680"/>
           </a:xfrm>
           <a:prstGeom prst="rect">
             <a:avLst/>
@@ -10597,27 +10690,27 @@
           <a:p>
             <a:pPr algn="l"/>
             <a:r>
-              <a:rPr sz="1500" b="0" i="0">
+              <a:rPr sz="1300" b="0" i="0">
                 <a:solidFill>
                   <a:srgbClr val="111827"/>
                 </a:solidFill>
-                <a:latin typeface="Calibri"/>
-              </a:rPr>
-              <a:t>Demostración y taller de 45 minutos; entrega del programa y del manual de usuario.</a:t>
-            </a:r>
-          </a:p>
-        </p:txBody>
-      </p:sp>
-      <p:sp>
-        <p:nvSpPr>
-          <p:cNvPr id="11" name="Rounded Rectangle 10"/>
+                <a:latin typeface="Times New Roman"/>
+              </a:rPr>
+              <a:t>Triángulo con la herramienta Polígono, traslación T(3, 0), zoom, Borrar y Reiniciar todo.</a:t>
+            </a:r>
+          </a:p>
+        </p:txBody>
+      </p:sp>
+      <p:sp>
+        <p:nvSpPr>
+          <p:cNvPr id="14" name="Rounded Rectangle 13"/>
           <p:cNvSpPr/>
           <p:nvPr/>
         </p:nvSpPr>
         <p:spPr>
           <a:xfrm>
-            <a:off x="548640" y="3520439"/>
-            <a:ext cx="5440680" cy="1874519"/>
+            <a:off x="8046719" y="4206240"/>
+            <a:ext cx="3611880" cy="1600200"/>
           </a:xfrm>
           <a:prstGeom prst="roundRect">
             <a:avLst>
@@ -10656,13 +10749,13 @@
       </p:sp>
       <p:sp>
         <p:nvSpPr>
-          <p:cNvPr id="12" name="Oval 11"/>
+          <p:cNvPr id="15" name="Oval 14"/>
           <p:cNvSpPr/>
           <p:nvPr/>
         </p:nvSpPr>
         <p:spPr>
           <a:xfrm>
-            <a:off x="822959" y="3794759"/>
+            <a:off x="8275319" y="4434840"/>
             <a:ext cx="502920" cy="502920"/>
           </a:xfrm>
           <a:prstGeom prst="ellipse">
@@ -10699,7 +10792,7 @@
                 <a:solidFill>
                   <a:srgbClr val="1E3A8A"/>
                 </a:solidFill>
-                <a:latin typeface="Calibri"/>
+                <a:latin typeface="Times New Roman"/>
               </a:rPr>
               <a:t>3</a:t>
             </a:r>
@@ -10708,14 +10801,14 @@
       </p:sp>
       <p:sp>
         <p:nvSpPr>
-          <p:cNvPr id="13" name="TextBox 12"/>
+          <p:cNvPr id="16" name="TextBox 15"/>
           <p:cNvSpPr txBox="1"/>
           <p:nvPr/>
         </p:nvSpPr>
         <p:spPr>
           <a:xfrm>
-            <a:off x="1508760" y="3794759"/>
-            <a:ext cx="4206240" cy="457200"/>
+            <a:off x="8915399" y="4434840"/>
+            <a:ext cx="2651760" cy="457200"/>
           </a:xfrm>
           <a:prstGeom prst="rect">
             <a:avLst/>
@@ -10730,27 +10823,27 @@
           <a:p>
             <a:pPr algn="l"/>
             <a:r>
-              <a:rPr sz="2000" b="1" i="0">
+              <a:rPr sz="1800" b="1" i="0">
                 <a:solidFill>
                   <a:srgbClr val="1E3A8A"/>
                 </a:solidFill>
-                <a:latin typeface="Calibri"/>
-              </a:rPr>
-              <a:t>Evidencias</a:t>
-            </a:r>
-          </a:p>
-        </p:txBody>
-      </p:sp>
-      <p:sp>
-        <p:nvSpPr>
-          <p:cNvPr id="14" name="TextBox 13"/>
+                <a:latin typeface="Times New Roman"/>
+              </a:rPr>
+              <a:t>Siguiente etapa</a:t>
+            </a:r>
+          </a:p>
+        </p:txBody>
+      </p:sp>
+      <p:sp>
+        <p:nvSpPr>
+          <p:cNvPr id="17" name="TextBox 16"/>
           <p:cNvSpPr txBox="1"/>
           <p:nvPr/>
         </p:nvSpPr>
         <p:spPr>
           <a:xfrm>
-            <a:off x="1508760" y="4297679"/>
-            <a:ext cx="4206240" cy="1005840"/>
+            <a:off x="8275319" y="4937759"/>
+            <a:ext cx="3200400" cy="868680"/>
           </a:xfrm>
           <a:prstGeom prst="rect">
             <a:avLst/>
@@ -10765,125 +10858,27 @@
           <a:p>
             <a:pPr algn="l"/>
             <a:r>
-              <a:rPr sz="1500" b="0" i="0">
+              <a:rPr sz="1300" b="0" i="0">
                 <a:solidFill>
                   <a:srgbClr val="111827"/>
                 </a:solidFill>
-                <a:latin typeface="Calibri"/>
-              </a:rPr>
-              <a:t>Ficha de la actividad, lista de asistentes, fotos con consentimiento y constancia.</a:t>
-            </a:r>
-          </a:p>
-        </p:txBody>
-      </p:sp>
-      <p:sp>
-        <p:nvSpPr>
-          <p:cNvPr id="15" name="Rounded Rectangle 14"/>
-          <p:cNvSpPr/>
-          <p:nvPr/>
-        </p:nvSpPr>
-        <p:spPr>
-          <a:xfrm>
-            <a:off x="6172200" y="3520439"/>
-            <a:ext cx="5440680" cy="1874519"/>
-          </a:xfrm>
-          <a:prstGeom prst="roundRect">
-            <a:avLst>
-              <a:gd name="adj" fmla="val 8000"/>
-            </a:avLst>
-          </a:prstGeom>
-          <a:solidFill>
-            <a:srgbClr val="EFF6FF"/>
-          </a:solidFill>
-          <a:ln>
-            <a:noFill/>
-          </a:ln>
-          <a:effectLst/>
-        </p:spPr>
-        <p:style>
-          <a:lnRef idx="1">
-            <a:schemeClr val="accent1"/>
-          </a:lnRef>
-          <a:fillRef idx="3">
-            <a:schemeClr val="accent1"/>
-          </a:fillRef>
-          <a:effectRef idx="2">
-            <a:schemeClr val="accent1"/>
-          </a:effectRef>
-          <a:fontRef idx="minor">
-            <a:schemeClr val="lt1"/>
-          </a:fontRef>
-        </p:style>
-        <p:txBody>
-          <a:bodyPr rtlCol="0" anchor="ctr"/>
-          <a:lstStyle/>
-          <a:p>
-            <a:pPr algn="ctr"/>
-          </a:p>
-        </p:txBody>
-      </p:sp>
-      <p:sp>
-        <p:nvSpPr>
-          <p:cNvPr id="16" name="Oval 15"/>
-          <p:cNvSpPr/>
-          <p:nvPr/>
-        </p:nvSpPr>
-        <p:spPr>
-          <a:xfrm>
-            <a:off x="6446520" y="3794759"/>
-            <a:ext cx="502920" cy="502920"/>
-          </a:xfrm>
-          <a:prstGeom prst="ellipse">
-            <a:avLst/>
-          </a:prstGeom>
-          <a:solidFill>
-            <a:srgbClr val="FBBF24"/>
-          </a:solidFill>
-          <a:ln>
-            <a:noFill/>
-          </a:ln>
-        </p:spPr>
-        <p:style>
-          <a:lnRef idx="1">
-            <a:schemeClr val="accent1"/>
-          </a:lnRef>
-          <a:fillRef idx="3">
-            <a:schemeClr val="accent1"/>
-          </a:fillRef>
-          <a:effectRef idx="2">
-            <a:schemeClr val="accent1"/>
-          </a:effectRef>
-          <a:fontRef idx="minor">
-            <a:schemeClr val="lt1"/>
-          </a:fontRef>
-        </p:style>
-        <p:txBody>
-          <a:bodyPr rtlCol="0" anchor="ctr" lIns="0" rIns="0" tIns="0" bIns="0"/>
-          <a:lstStyle/>
-          <a:p>
-            <a:pPr algn="ctr"/>
-            <a:r>
-              <a:rPr sz="1800" b="1">
-                <a:solidFill>
-                  <a:srgbClr val="1E3A8A"/>
-                </a:solidFill>
-                <a:latin typeface="Calibri"/>
-              </a:rPr>
-              <a:t>4</a:t>
-            </a:r>
-          </a:p>
-        </p:txBody>
-      </p:sp>
-      <p:sp>
-        <p:nvSpPr>
-          <p:cNvPr id="17" name="TextBox 16"/>
+                <a:latin typeface="Times New Roman"/>
+              </a:rPr>
+              <a:t>Con el programa mejorado: taller en la institución, lista firmada, encuesta y constancia.</a:t>
+            </a:r>
+          </a:p>
+        </p:txBody>
+      </p:sp>
+      <p:sp>
+        <p:nvSpPr>
+          <p:cNvPr id="18" name="TextBox 17"/>
           <p:cNvSpPr txBox="1"/>
           <p:nvPr/>
         </p:nvSpPr>
         <p:spPr>
           <a:xfrm>
-            <a:off x="7132320" y="3794759"/>
-            <a:ext cx="4206240" cy="457200"/>
+            <a:off x="548640" y="5897880"/>
+            <a:ext cx="11064240" cy="411480"/>
           </a:xfrm>
           <a:prstGeom prst="rect">
             <a:avLst/>
@@ -10898,27 +10893,36 @@
           <a:p>
             <a:pPr algn="l"/>
             <a:r>
-              <a:rPr sz="2000" b="1" i="0">
-                <a:solidFill>
-                  <a:srgbClr val="1E3A8A"/>
-                </a:solidFill>
-                <a:latin typeface="Calibri"/>
-              </a:rPr>
-              <a:t>Indicadores</a:t>
-            </a:r>
-          </a:p>
-        </p:txBody>
-      </p:sp>
-      <p:sp>
-        <p:nvSpPr>
-          <p:cNvPr id="18" name="TextBox 17"/>
+              <a:rPr sz="1300" b="1" i="0">
+                <a:solidFill>
+                  <a:srgbClr val="4B5563"/>
+                </a:solidFill>
+                <a:latin typeface="Times New Roman"/>
+              </a:rPr>
+              <a:t>Estado: </a:t>
+            </a:r>
+            <a:r>
+              <a:rPr sz="1300" b="0" i="0">
+                <a:solidFill>
+                  <a:srgbClr val="4B5563"/>
+                </a:solidFill>
+                <a:latin typeface="Times New Roman"/>
+              </a:rPr>
+              <a:t>realizada con los 3 integrantes y con el consentimiento del docente para las imágenes; falta registrar su opinión.</a:t>
+            </a:r>
+          </a:p>
+        </p:txBody>
+      </p:sp>
+      <p:sp>
+        <p:nvSpPr>
+          <p:cNvPr id="19" name="TextBox 18"/>
           <p:cNvSpPr txBox="1"/>
           <p:nvPr/>
         </p:nvSpPr>
         <p:spPr>
           <a:xfrm>
-            <a:off x="7132320" y="4297679"/>
-            <a:ext cx="4206240" cy="1005840"/>
+            <a:off x="548640" y="6400800"/>
+            <a:ext cx="7315200" cy="274320"/>
           </a:xfrm>
           <a:prstGeom prst="rect">
             <a:avLst/>
@@ -10933,27 +10937,27 @@
           <a:p>
             <a:pPr algn="l"/>
             <a:r>
-              <a:rPr sz="1500" b="0" i="0">
-                <a:solidFill>
-                  <a:srgbClr val="111827"/>
-                </a:solidFill>
-                <a:latin typeface="Calibri"/>
-              </a:rPr>
-              <a:t>Docentes participantes, % que aplica una composición y valoración en la encuesta.</a:t>
-            </a:r>
-          </a:p>
-        </p:txBody>
-      </p:sp>
-      <p:sp>
-        <p:nvSpPr>
-          <p:cNvPr id="19" name="TextBox 18"/>
+              <a:rPr sz="1000" b="0" i="0">
+                <a:solidFill>
+                  <a:srgbClr val="4B5563"/>
+                </a:solidFill>
+                <a:latin typeface="Times New Roman"/>
+              </a:rPr>
+              <a:t>GeoMatriz 2D · Grupo 3 · Computación Gráfica (IIAD65)</a:t>
+            </a:r>
+          </a:p>
+        </p:txBody>
+      </p:sp>
+      <p:sp>
+        <p:nvSpPr>
+          <p:cNvPr id="20" name="TextBox 19"/>
           <p:cNvSpPr txBox="1"/>
           <p:nvPr/>
         </p:nvSpPr>
         <p:spPr>
           <a:xfrm>
-            <a:off x="548640" y="5806440"/>
-            <a:ext cx="11064240" cy="457200"/>
+            <a:off x="10698480" y="6400800"/>
+            <a:ext cx="914400" cy="274320"/>
           </a:xfrm>
           <a:prstGeom prst="rect">
             <a:avLst/>
@@ -10966,92 +10970,13 @@
           </a:bodyPr>
           <a:lstStyle/>
           <a:p>
-            <a:pPr algn="l"/>
-            <a:r>
-              <a:rPr sz="1400" b="1" i="0">
+            <a:pPr algn="r"/>
+            <a:r>
+              <a:rPr sz="1000" b="0" i="0">
                 <a:solidFill>
                   <a:srgbClr val="4B5563"/>
                 </a:solidFill>
-                <a:latin typeface="Calibri"/>
-              </a:rPr>
-              <a:t>Estado: </a:t>
-            </a:r>
-            <a:r>
-              <a:rPr sz="1400" b="0" i="0">
-                <a:solidFill>
-                  <a:srgbClr val="4B5563"/>
-                </a:solidFill>
-                <a:latin typeface="Calibri"/>
-              </a:rPr>
-              <a:t>actividad programada; las evidencias se registrarán cuando se realice. El programa no recoge datos personales y las fotos solo se usarán con consentimiento.</a:t>
-            </a:r>
-          </a:p>
-        </p:txBody>
-      </p:sp>
-      <p:sp>
-        <p:nvSpPr>
-          <p:cNvPr id="20" name="TextBox 19"/>
-          <p:cNvSpPr txBox="1"/>
-          <p:nvPr/>
-        </p:nvSpPr>
-        <p:spPr>
-          <a:xfrm>
-            <a:off x="548640" y="6400800"/>
-            <a:ext cx="7315200" cy="274320"/>
-          </a:xfrm>
-          <a:prstGeom prst="rect">
-            <a:avLst/>
-          </a:prstGeom>
-          <a:noFill/>
-        </p:spPr>
-        <p:txBody>
-          <a:bodyPr wrap="square" lIns="0" rIns="0" tIns="0" bIns="0" anchor="t">
-            <a:spAutoFit/>
-          </a:bodyPr>
-          <a:lstStyle/>
-          <a:p>
-            <a:pPr algn="l"/>
-            <a:r>
-              <a:rPr sz="1000" b="0" i="0">
-                <a:solidFill>
-                  <a:srgbClr val="4B5563"/>
-                </a:solidFill>
-                <a:latin typeface="Calibri"/>
-              </a:rPr>
-              <a:t>GeoMatriz 2D · Grupo 3 · Computación Gráfica (IIAD65)</a:t>
-            </a:r>
-          </a:p>
-        </p:txBody>
-      </p:sp>
-      <p:sp>
-        <p:nvSpPr>
-          <p:cNvPr id="21" name="TextBox 20"/>
-          <p:cNvSpPr txBox="1"/>
-          <p:nvPr/>
-        </p:nvSpPr>
-        <p:spPr>
-          <a:xfrm>
-            <a:off x="10698480" y="6400800"/>
-            <a:ext cx="914400" cy="274320"/>
-          </a:xfrm>
-          <a:prstGeom prst="rect">
-            <a:avLst/>
-          </a:prstGeom>
-          <a:noFill/>
-        </p:spPr>
-        <p:txBody>
-          <a:bodyPr wrap="square" lIns="0" rIns="0" tIns="0" bIns="0" anchor="t">
-            <a:spAutoFit/>
-          </a:bodyPr>
-          <a:lstStyle/>
-          <a:p>
-            <a:pPr algn="r"/>
-            <a:r>
-              <a:rPr sz="1000" b="0" i="0">
-                <a:solidFill>
-                  <a:srgbClr val="4B5563"/>
-                </a:solidFill>
-                <a:latin typeface="Calibri"/>
+                <a:latin typeface="Times New Roman"/>
               </a:rPr>
               <a:t>9</a:t>
             </a:r>

</xml_diff>